<commit_message>
Fix base-template cover authored in Roboto (palette-fonts vs cover-fidelity conflict)
The shipped strict/free-form base-template covers (and the strict agenda) used
Roboto / Roboto Mono Medium. audit_palette_fonts.py forbids those (system-fonts
only — Roboto crashes Keynote import), but audit_cover_fidelity.py wants the
render's cover to match the template's cover. The two hard audits contradicted
each other on the shipped asset — no strict render could pass both.

Rewrote the cover + agenda font runs to the fonts the §4.3 recipe already
documents: Helvetica Bold (title/subtitle) + Helvetica (author/date). Now
template = spec = allowed palette; both audits agree. Verified: free-form
template 0 off-font; strict cover+agenda 0 off-font (slides 3-15 are the
deleted layout-reference zone).

Bump to 0.10.3.

Co-Authored-By: Claude Opus 4.8 (1M context) <noreply@anthropic.com>
</commit_message>
<xml_diff>
--- a/config/pptx-styles/free-form/base-template.pptx
+++ b/config/pptx-styles/free-form/base-template.pptx
@@ -1259,7 +1259,7 @@
                 <a:solidFill>
                   <a:srgbClr val="1F1E1E"/>
                 </a:solidFill>
-                <a:latin typeface="Roboto Mono Medium" pitchFamily="34" charset="0"/>
+                <a:latin typeface="Helvetica Bold" pitchFamily="34" charset="0"/>
                 <a:ea typeface="Roboto Mono Medium" pitchFamily="34" charset="-122"/>
                 <a:cs typeface="Roboto Mono Medium" pitchFamily="34" charset="-120"/>
               </a:rPr>
@@ -1301,7 +1301,7 @@
                 <a:solidFill>
                   <a:srgbClr val="1F1E1E"/>
                 </a:solidFill>
-                <a:latin typeface="Roboto Mono Medium" pitchFamily="34" charset="0"/>
+                <a:latin typeface="Helvetica Bold" pitchFamily="34" charset="0"/>
                 <a:ea typeface="Roboto Mono Medium" pitchFamily="34" charset="-122"/>
                 <a:cs typeface="Roboto Mono Medium" pitchFamily="34" charset="-120"/>
               </a:rPr>
@@ -1346,7 +1346,7 @@
                 <a:solidFill>
                   <a:srgbClr val="3B3535"/>
                 </a:solidFill>
-                <a:latin typeface="Roboto" pitchFamily="34" charset="0"/>
+                <a:latin typeface="Helvetica" pitchFamily="34" charset="0"/>
                 <a:ea typeface="Roboto" pitchFamily="34" charset="-122"/>
                 <a:cs typeface="Roboto" pitchFamily="34" charset="-120"/>
               </a:rPr>
@@ -1366,7 +1366,7 @@
                 <a:solidFill>
                   <a:srgbClr val="3B3535"/>
                 </a:solidFill>
-                <a:latin typeface="Roboto" pitchFamily="34" charset="0"/>
+                <a:latin typeface="Helvetica" pitchFamily="34" charset="0"/>
                 <a:ea typeface="Roboto" pitchFamily="34" charset="-122"/>
                 <a:cs typeface="Roboto" pitchFamily="34" charset="-120"/>
               </a:rPr>

</xml_diff>